<commit_message>
Deploy to Agent Engine as an A2A agent; git-less repo fetch, signed report links, Agent Engine client example
Co-Authored-By: Claude Sonnet 5.5 <noreply@anthropic.com>
Claude-Session: https://claude.ai/code/session_01WhGD5BSnbjckgDrsoyqpPK
</commit_message>
<xml_diff>
--- a/ppt/CodeMender_Overview.pptx
+++ b/ppt/CodeMender_Overview.pptx
@@ -9342,7 +9342,7 @@
                 </a:solidFill>
                 <a:latin typeface="Calibri"/>
               </a:rPr>
-              <a:t>ADK · A2A server</a:t>
+              <a:t>ADK · Agent Engine (A2A)</a:t>
             </a:r>
           </a:p>
           <a:p>
@@ -9574,7 +9574,7 @@
                 </a:solidFill>
                 <a:latin typeface="Calibri"/>
               </a:rPr>
-              <a:t>A2A: agent card at /.well-known/agent-card.json · JSON-RPC · IAM-authenticated on Cloud Run</a:t>
+              <a:t>A2A over Vertex AI Agent Engine · IAM-authenticated · both agents registered in Gemini Enterprise</a:t>
             </a:r>
           </a:p>
         </p:txBody>

</xml_diff>

<commit_message>
Deliver a single PDF report inline over A2A (no bucket); remove GCS/signed-URL code
Co-Authored-By: Claude Sonnet 5.5 <noreply@anthropic.com>
Claude-Session: https://claude.ai/code/session_01WhGD5BSnbjckgDrsoyqpPK
</commit_message>
<xml_diff>
--- a/ppt/CodeMender_Overview.pptx
+++ b/ppt/CodeMender_Overview.pptx
@@ -7909,7 +7909,7 @@
         <p:spPr>
           <a:xfrm>
             <a:off x="6675120" y="1371600"/>
-            <a:ext cx="5120640" cy="4655127"/>
+            <a:ext cx="5120640" cy="7232775"/>
           </a:xfrm>
           <a:prstGeom prst="rect">
             <a:avLst/>
@@ -7994,7 +7994,7 @@
                 </a:solidFill>
                 <a:latin typeface="Calibri"/>
               </a:rPr>
-              <a:t>Interactive HTML dashboard</a:t>
+              <a:t>One PDF security report</a:t>
             </a:r>
           </a:p>
         </p:txBody>
@@ -8033,7 +8033,7 @@
                 </a:solidFill>
                 <a:latin typeface="Calibri"/>
               </a:rPr>
-              <a:t>risk score, severity donut, OWASP exposure, filterable findings</a:t>
+              <a:t>delivered straight into Gemini Enterprise, nothing stored</a:t>
             </a:r>
           </a:p>
         </p:txBody>
@@ -8116,7 +8116,7 @@
                 </a:solidFill>
                 <a:latin typeface="Calibri"/>
               </a:rPr>
-              <a:t>Markdown executive summary</a:t>
+              <a:t>Risk score and severity chart</a:t>
             </a:r>
           </a:p>
         </p:txBody>
@@ -8155,7 +8155,7 @@
                 </a:solidFill>
                 <a:latin typeface="Calibri"/>
               </a:rPr>
-              <a:t>paste into tickets / chat</a:t>
+              <a:t>at-a-glance posture of the repository</a:t>
             </a:r>
           </a:p>
         </p:txBody>
@@ -8238,7 +8238,7 @@
                 </a:solidFill>
                 <a:latin typeface="Calibri"/>
               </a:rPr>
-              <a:t>SARIF 2.1.0</a:t>
+              <a:t>OWASP Top 10 + CWE mapping</a:t>
             </a:r>
           </a:p>
         </p:txBody>
@@ -8277,7 +8277,7 @@
                 </a:solidFill>
                 <a:latin typeface="Calibri"/>
               </a:rPr>
-              <a:t>GitHub code scanning, IDEs, DevSecOps pipelines</a:t>
+              <a:t>audit-friendly categorisation of every finding</a:t>
             </a:r>
           </a:p>
         </p:txBody>
@@ -8360,7 +8360,7 @@
                 </a:solidFill>
                 <a:latin typeface="Calibri"/>
               </a:rPr>
-              <a:t>JSON + CSV</a:t>
+              <a:t>Per-finding detail</a:t>
             </a:r>
           </a:p>
         </p:txBody>
@@ -8399,7 +8399,7 @@
                 </a:solidFill>
                 <a:latin typeface="Calibri"/>
               </a:rPr>
-              <a:t>dashboards, audit evidence, import to other tools</a:t>
+              <a:t>why it matters, recommended fix, verification plan</a:t>
             </a:r>
           </a:p>
         </p:txBody>
@@ -8482,7 +8482,7 @@
                 </a:solidFill>
                 <a:latin typeface="Calibri"/>
               </a:rPr>
-              <a:t>Patch set (unified diff)</a:t>
+              <a:t>Proposed patches (diff)</a:t>
             </a:r>
           </a:p>
         </p:txBody>
@@ -8604,7 +8604,7 @@
                 </a:solidFill>
                 <a:latin typeface="Calibri"/>
               </a:rPr>
-              <a:t>Per-finding detail</a:t>
+              <a:t>Text summary in chat</a:t>
             </a:r>
           </a:p>
         </p:txBody>
@@ -8643,7 +8643,7 @@
                 </a:solidFill>
                 <a:latin typeface="Calibri"/>
               </a:rPr>
-              <a:t>CWE, OWASP, why it matters, fix, verification plan</a:t>
+              <a:t>key findings even if the PDF is not rendered</a:t>
             </a:r>
           </a:p>
         </p:txBody>

</xml_diff>

<commit_message>
Deck: show the sandboxed CodeMender runner in the architecture slide
Co-Authored-By: Claude Sonnet 5.5 <noreply@anthropic.com>
Claude-Session: https://claude.ai/code/session_01WhGD5BSnbjckgDrsoyqpPK
</commit_message>
<xml_diff>
--- a/ppt/CodeMender_Overview.pptx
+++ b/ppt/CodeMender_Overview.pptx
@@ -9358,7 +9358,7 @@
                 </a:solidFill>
                 <a:latin typeface="Calibri"/>
               </a:rPr>
-              <a:t>Find · Verify plan · Fix</a:t>
+              <a:t>Orchestrates + builds PDF</a:t>
             </a:r>
           </a:p>
         </p:txBody>
@@ -9480,7 +9480,7 @@
                 </a:solidFill>
                 <a:latin typeface="Calibri"/>
               </a:rPr>
-              <a:t>Git repository</a:t>
+              <a:t>CodeMender Runner</a:t>
             </a:r>
           </a:p>
         </p:txBody>
@@ -9519,7 +9519,7 @@
                 </a:solidFill>
                 <a:latin typeface="Calibri"/>
               </a:rPr>
-              <a:t>Cloned read-only,</a:t>
+              <a:t>Cloud Run sandbox · cm CLI</a:t>
             </a:r>
           </a:p>
           <a:p>
@@ -9535,7 +9535,7 @@
                 </a:solidFill>
                 <a:latin typeface="Calibri"/>
               </a:rPr>
-              <a:t>scanned, discarded</a:t>
+              <a:t>find · verify · fix</a:t>
             </a:r>
           </a:p>
         </p:txBody>

</xml_diff>

<commit_message>
Simplify: plain ADK scan agent deployed as AdkApp; park A2A, runner and cm work in future/
Co-Authored-By: Claude Sonnet 5.5 <noreply@anthropic.com>
Claude-Session: https://claude.ai/code/session_01WhGD5BSnbjckgDrsoyqpPK
</commit_message>
<xml_diff>
--- a/ppt/CodeMender_Overview.pptx
+++ b/ppt/CodeMender_Overview.pptx
@@ -8788,7 +8788,7 @@
                 </a:solidFill>
                 <a:latin typeface="Calibri"/>
               </a:rPr>
-              <a:t>Demo architecture: agents working together via A2A</a:t>
+              <a:t>Demo architecture</a:t>
             </a:r>
           </a:p>
         </p:txBody>
@@ -8801,8 +8801,8 @@
         </p:nvSpPr>
         <p:spPr>
           <a:xfrm>
-            <a:off x="457200" y="6446520"/>
-            <a:ext cx="7315200" cy="274320"/>
+            <a:off x="457200" y="621792"/>
+            <a:ext cx="10972800" cy="365760"/>
           </a:xfrm>
           <a:prstGeom prst="rect">
             <a:avLst/>
@@ -8821,13 +8821,13 @@
               </a:spcAft>
             </a:pPr>
             <a:r>
-              <a:rPr sz="1000" b="0">
-                <a:solidFill>
-                  <a:srgbClr val="5F6368"/>
-                </a:solidFill>
-                <a:latin typeface="Calibri"/>
-              </a:rPr>
-              <a:t>CodeMender · Code security agent</a:t>
+              <a:rPr sz="1400" b="0">
+                <a:solidFill>
+                  <a:srgbClr val="BBD3F7"/>
+                </a:solidFill>
+                <a:latin typeface="Calibri"/>
+              </a:rPr>
+              <a:t>A simple agent: repo in, security report out</a:t>
             </a:r>
           </a:p>
         </p:txBody>
@@ -8840,8 +8840,8 @@
         </p:nvSpPr>
         <p:spPr>
           <a:xfrm>
-            <a:off x="11094415" y="6446520"/>
-            <a:ext cx="731520" cy="274320"/>
+            <a:off x="457200" y="6446520"/>
+            <a:ext cx="7315200" cy="274320"/>
           </a:xfrm>
           <a:prstGeom prst="rect">
             <a:avLst/>
@@ -8854,6 +8854,45 @@
           </a:bodyPr>
           <a:lstStyle/>
           <a:p>
+            <a:pPr algn="l">
+              <a:spcAft>
+                <a:spcPts val="600"/>
+              </a:spcAft>
+            </a:pPr>
+            <a:r>
+              <a:rPr sz="1000" b="0">
+                <a:solidFill>
+                  <a:srgbClr val="5F6368"/>
+                </a:solidFill>
+                <a:latin typeface="Calibri"/>
+              </a:rPr>
+              <a:t>CodeMender · Code security agent</a:t>
+            </a:r>
+          </a:p>
+        </p:txBody>
+      </p:sp>
+      <p:sp>
+        <p:nvSpPr>
+          <p:cNvPr id="7" name="TextBox 6"/>
+          <p:cNvSpPr txBox="1"/>
+          <p:nvPr/>
+        </p:nvSpPr>
+        <p:spPr>
+          <a:xfrm>
+            <a:off x="11094415" y="6446520"/>
+            <a:ext cx="731520" cy="274320"/>
+          </a:xfrm>
+          <a:prstGeom prst="rect">
+            <a:avLst/>
+          </a:prstGeom>
+          <a:noFill/>
+        </p:spPr>
+        <p:txBody>
+          <a:bodyPr wrap="square" anchor="t">
+            <a:spAutoFit/>
+          </a:bodyPr>
+          <a:lstStyle/>
+          <a:p>
             <a:pPr algn="r">
               <a:spcAft>
                 <a:spcPts val="600"/>
@@ -8873,7 +8912,7 @@
       </p:sp>
       <p:sp>
         <p:nvSpPr>
-          <p:cNvPr id="7" name="Rounded Rectangle 6"/>
+          <p:cNvPr id="8" name="Rounded Rectangle 7"/>
           <p:cNvSpPr/>
           <p:nvPr/>
         </p:nvSpPr>
@@ -8917,7 +8956,7 @@
       </p:sp>
       <p:sp>
         <p:nvSpPr>
-          <p:cNvPr id="8" name="TextBox 7"/>
+          <p:cNvPr id="9" name="TextBox 8"/>
           <p:cNvSpPr txBox="1"/>
           <p:nvPr/>
         </p:nvSpPr>
@@ -8956,7 +8995,7 @@
       </p:sp>
       <p:sp>
         <p:nvSpPr>
-          <p:cNvPr id="9" name="TextBox 8"/>
+          <p:cNvPr id="10" name="TextBox 9"/>
           <p:cNvSpPr txBox="1"/>
           <p:nvPr/>
         </p:nvSpPr>
@@ -8988,7 +9027,7 @@
                 </a:solidFill>
                 <a:latin typeface="Calibri"/>
               </a:rPr>
-              <a:t>User asks:</a:t>
+              <a:t>User pastes a</a:t>
             </a:r>
           </a:p>
           <a:p>
@@ -9004,14 +9043,14 @@
                 </a:solidFill>
                 <a:latin typeface="Calibri"/>
               </a:rPr>
-              <a:t>“Analyse and fix this repo”</a:t>
-            </a:r>
-          </a:p>
-        </p:txBody>
-      </p:sp>
-      <p:sp>
-        <p:nvSpPr>
-          <p:cNvPr id="10" name="TextBox 9"/>
+              <a:t>GitHub repo link</a:t>
+            </a:r>
+          </a:p>
+        </p:txBody>
+      </p:sp>
+      <p:sp>
+        <p:nvSpPr>
+          <p:cNvPr id="11" name="TextBox 10"/>
           <p:cNvSpPr txBox="1"/>
           <p:nvPr/>
         </p:nvSpPr>
@@ -9050,7 +9089,7 @@
       </p:sp>
       <p:sp>
         <p:nvSpPr>
-          <p:cNvPr id="11" name="Rounded Rectangle 10"/>
+          <p:cNvPr id="12" name="Rounded Rectangle 11"/>
           <p:cNvSpPr/>
           <p:nvPr/>
         </p:nvSpPr>
@@ -9094,7 +9133,7 @@
       </p:sp>
       <p:sp>
         <p:nvSpPr>
-          <p:cNvPr id="12" name="TextBox 11"/>
+          <p:cNvPr id="13" name="TextBox 12"/>
           <p:cNvSpPr txBox="1"/>
           <p:nvPr/>
         </p:nvSpPr>
@@ -9126,14 +9165,14 @@
                 </a:solidFill>
                 <a:latin typeface="Calibri"/>
               </a:rPr>
-              <a:t>Defect-Fix Agent</a:t>
-            </a:r>
-          </a:p>
-        </p:txBody>
-      </p:sp>
-      <p:sp>
-        <p:nvSpPr>
-          <p:cNvPr id="13" name="TextBox 12"/>
+              <a:t>CodeMender Scan Agent</a:t>
+            </a:r>
+          </a:p>
+        </p:txBody>
+      </p:sp>
+      <p:sp>
+        <p:nvSpPr>
+          <p:cNvPr id="14" name="TextBox 13"/>
           <p:cNvSpPr txBox="1"/>
           <p:nvPr/>
         </p:nvSpPr>
@@ -9181,14 +9220,14 @@
                 </a:solidFill>
                 <a:latin typeface="Calibri"/>
               </a:rPr>
-              <a:t>Orchestrates the fix</a:t>
-            </a:r>
-          </a:p>
-        </p:txBody>
-      </p:sp>
-      <p:sp>
-        <p:nvSpPr>
-          <p:cNvPr id="14" name="TextBox 13"/>
+              <a:t>Orchestrates the scan</a:t>
+            </a:r>
+          </a:p>
+        </p:txBody>
+      </p:sp>
+      <p:sp>
+        <p:nvSpPr>
+          <p:cNvPr id="15" name="TextBox 14"/>
           <p:cNvSpPr txBox="1"/>
           <p:nvPr/>
         </p:nvSpPr>
@@ -9227,13 +9266,190 @@
       </p:sp>
       <p:sp>
         <p:nvSpPr>
-          <p:cNvPr id="15" name="Rounded Rectangle 14"/>
+          <p:cNvPr id="16" name="Rounded Rectangle 15"/>
           <p:cNvSpPr/>
           <p:nvPr/>
         </p:nvSpPr>
         <p:spPr>
           <a:xfrm>
             <a:off x="6217920" y="1828800"/>
+            <a:ext cx="2560320" cy="1737360"/>
+          </a:xfrm>
+          <a:prstGeom prst="roundRect">
+            <a:avLst/>
+          </a:prstGeom>
+          <a:solidFill>
+            <a:srgbClr val="E8710A"/>
+          </a:solidFill>
+          <a:ln>
+            <a:noFill/>
+          </a:ln>
+          <a:effectLst/>
+        </p:spPr>
+        <p:style>
+          <a:lnRef idx="1">
+            <a:schemeClr val="accent1"/>
+          </a:lnRef>
+          <a:fillRef idx="3">
+            <a:schemeClr val="accent1"/>
+          </a:fillRef>
+          <a:effectRef idx="2">
+            <a:schemeClr val="accent1"/>
+          </a:effectRef>
+          <a:fontRef idx="minor">
+            <a:schemeClr val="lt1"/>
+          </a:fontRef>
+        </p:style>
+        <p:txBody>
+          <a:bodyPr rtlCol="0" anchor="ctr"/>
+          <a:lstStyle/>
+          <a:p>
+            <a:pPr algn="ctr"/>
+          </a:p>
+        </p:txBody>
+      </p:sp>
+      <p:sp>
+        <p:nvSpPr>
+          <p:cNvPr id="17" name="TextBox 16"/>
+          <p:cNvSpPr txBox="1"/>
+          <p:nvPr/>
+        </p:nvSpPr>
+        <p:spPr>
+          <a:xfrm>
+            <a:off x="6217920" y="1920240"/>
+            <a:ext cx="2560320" cy="457200"/>
+          </a:xfrm>
+          <a:prstGeom prst="rect">
+            <a:avLst/>
+          </a:prstGeom>
+          <a:noFill/>
+        </p:spPr>
+        <p:txBody>
+          <a:bodyPr wrap="square" anchor="t">
+            <a:spAutoFit/>
+          </a:bodyPr>
+          <a:lstStyle/>
+          <a:p>
+            <a:pPr algn="ctr">
+              <a:spcAft>
+                <a:spcPts val="600"/>
+              </a:spcAft>
+            </a:pPr>
+            <a:r>
+              <a:rPr sz="1600" b="1">
+                <a:solidFill>
+                  <a:srgbClr val="FFFFFF"/>
+                </a:solidFill>
+                <a:latin typeface="Calibri"/>
+              </a:rPr>
+              <a:t>Repository</a:t>
+            </a:r>
+          </a:p>
+        </p:txBody>
+      </p:sp>
+      <p:sp>
+        <p:nvSpPr>
+          <p:cNvPr id="18" name="TextBox 17"/>
+          <p:cNvSpPr txBox="1"/>
+          <p:nvPr/>
+        </p:nvSpPr>
+        <p:spPr>
+          <a:xfrm>
+            <a:off x="6217920" y="2560320"/>
+            <a:ext cx="2560320" cy="914400"/>
+          </a:xfrm>
+          <a:prstGeom prst="rect">
+            <a:avLst/>
+          </a:prstGeom>
+          <a:noFill/>
+        </p:spPr>
+        <p:txBody>
+          <a:bodyPr wrap="square" anchor="t">
+            <a:spAutoFit/>
+          </a:bodyPr>
+          <a:lstStyle/>
+          <a:p>
+            <a:pPr algn="ctr">
+              <a:spcAft>
+                <a:spcPts val="600"/>
+              </a:spcAft>
+            </a:pPr>
+            <a:r>
+              <a:rPr sz="1300" b="0">
+                <a:solidFill>
+                  <a:srgbClr val="FFFFFF"/>
+                </a:solidFill>
+                <a:latin typeface="Calibri"/>
+              </a:rPr>
+              <a:t>Cloned read-only,</a:t>
+            </a:r>
+          </a:p>
+          <a:p>
+            <a:pPr algn="ctr">
+              <a:spcAft>
+                <a:spcPts val="600"/>
+              </a:spcAft>
+            </a:pPr>
+            <a:r>
+              <a:rPr sz="1300" b="0">
+                <a:solidFill>
+                  <a:srgbClr val="FFFFFF"/>
+                </a:solidFill>
+                <a:latin typeface="Calibri"/>
+              </a:rPr>
+              <a:t>scanned, discarded</a:t>
+            </a:r>
+          </a:p>
+        </p:txBody>
+      </p:sp>
+      <p:sp>
+        <p:nvSpPr>
+          <p:cNvPr id="19" name="TextBox 18"/>
+          <p:cNvSpPr txBox="1"/>
+          <p:nvPr/>
+        </p:nvSpPr>
+        <p:spPr>
+          <a:xfrm>
+            <a:off x="8732520" y="2377440"/>
+            <a:ext cx="457200" cy="548640"/>
+          </a:xfrm>
+          <a:prstGeom prst="rect">
+            <a:avLst/>
+          </a:prstGeom>
+          <a:noFill/>
+        </p:spPr>
+        <p:txBody>
+          <a:bodyPr wrap="square" anchor="t">
+            <a:spAutoFit/>
+          </a:bodyPr>
+          <a:lstStyle/>
+          <a:p>
+            <a:pPr algn="l">
+              <a:spcAft>
+                <a:spcPts val="600"/>
+              </a:spcAft>
+            </a:pPr>
+            <a:r>
+              <a:rPr sz="2800" b="1">
+                <a:solidFill>
+                  <a:srgbClr val="5F6368"/>
+                </a:solidFill>
+                <a:latin typeface="Calibri"/>
+              </a:rPr>
+              <a:t>→</a:t>
+            </a:r>
+          </a:p>
+        </p:txBody>
+      </p:sp>
+      <p:sp>
+        <p:nvSpPr>
+          <p:cNvPr id="20" name="Rounded Rectangle 19"/>
+          <p:cNvSpPr/>
+          <p:nvPr/>
+        </p:nvSpPr>
+        <p:spPr>
+          <a:xfrm>
+            <a:off x="9144000" y="1828800"/>
             <a:ext cx="2560320" cy="1737360"/>
           </a:xfrm>
           <a:prstGeom prst="roundRect">
@@ -9271,13 +9487,13 @@
       </p:sp>
       <p:sp>
         <p:nvSpPr>
-          <p:cNvPr id="16" name="TextBox 15"/>
+          <p:cNvPr id="21" name="TextBox 20"/>
           <p:cNvSpPr txBox="1"/>
           <p:nvPr/>
         </p:nvSpPr>
         <p:spPr>
           <a:xfrm>
-            <a:off x="6217920" y="1920240"/>
+            <a:off x="9144000" y="1920240"/>
             <a:ext cx="2560320" cy="457200"/>
           </a:xfrm>
           <a:prstGeom prst="rect">
@@ -9303,20 +9519,20 @@
                 </a:solidFill>
                 <a:latin typeface="Calibri"/>
               </a:rPr>
-              <a:t>CodeMender Analysis Agent</a:t>
-            </a:r>
-          </a:p>
-        </p:txBody>
-      </p:sp>
-      <p:sp>
-        <p:nvSpPr>
-          <p:cNvPr id="17" name="TextBox 16"/>
+              <a:t>PDF report</a:t>
+            </a:r>
+          </a:p>
+        </p:txBody>
+      </p:sp>
+      <p:sp>
+        <p:nvSpPr>
+          <p:cNvPr id="22" name="TextBox 21"/>
           <p:cNvSpPr txBox="1"/>
           <p:nvPr/>
         </p:nvSpPr>
         <p:spPr>
           <a:xfrm>
-            <a:off x="6217920" y="2560320"/>
+            <a:off x="9144000" y="2560320"/>
             <a:ext cx="2560320" cy="914400"/>
           </a:xfrm>
           <a:prstGeom prst="rect">
@@ -9342,7 +9558,7 @@
                 </a:solidFill>
                 <a:latin typeface="Calibri"/>
               </a:rPr>
-              <a:t>ADK · Agent Engine (A2A)</a:t>
+              <a:t>Risk score, findings,</a:t>
             </a:r>
           </a:p>
           <a:p>
@@ -9358,21 +9574,21 @@
                 </a:solidFill>
                 <a:latin typeface="Calibri"/>
               </a:rPr>
-              <a:t>Orchestrates + builds PDF</a:t>
-            </a:r>
-          </a:p>
-        </p:txBody>
-      </p:sp>
-      <p:sp>
-        <p:nvSpPr>
-          <p:cNvPr id="18" name="TextBox 17"/>
+              <a:t>CWE/OWASP, patches</a:t>
+            </a:r>
+          </a:p>
+        </p:txBody>
+      </p:sp>
+      <p:sp>
+        <p:nvSpPr>
+          <p:cNvPr id="23" name="TextBox 22"/>
           <p:cNvSpPr txBox="1"/>
           <p:nvPr/>
         </p:nvSpPr>
         <p:spPr>
           <a:xfrm>
-            <a:off x="8732520" y="2377440"/>
-            <a:ext cx="457200" cy="548640"/>
+            <a:off x="365760" y="3931920"/>
+            <a:ext cx="11430000" cy="2377440"/>
           </a:xfrm>
           <a:prstGeom prst="rect">
             <a:avLst/>
@@ -9391,176 +9607,15 @@
               </a:spcAft>
             </a:pPr>
             <a:r>
-              <a:rPr sz="2800" b="1">
-                <a:solidFill>
-                  <a:srgbClr val="5F6368"/>
-                </a:solidFill>
-                <a:latin typeface="Calibri"/>
-              </a:rPr>
-              <a:t>→</a:t>
-            </a:r>
-          </a:p>
-        </p:txBody>
-      </p:sp>
-      <p:sp>
-        <p:nvSpPr>
-          <p:cNvPr id="19" name="Rounded Rectangle 18"/>
-          <p:cNvSpPr/>
-          <p:nvPr/>
-        </p:nvSpPr>
-        <p:spPr>
-          <a:xfrm>
-            <a:off x="9144000" y="1828800"/>
-            <a:ext cx="2560320" cy="1737360"/>
-          </a:xfrm>
-          <a:prstGeom prst="roundRect">
-            <a:avLst/>
-          </a:prstGeom>
-          <a:solidFill>
-            <a:srgbClr val="E8710A"/>
-          </a:solidFill>
-          <a:ln>
-            <a:noFill/>
-          </a:ln>
-          <a:effectLst/>
-        </p:spPr>
-        <p:style>
-          <a:lnRef idx="1">
-            <a:schemeClr val="accent1"/>
-          </a:lnRef>
-          <a:fillRef idx="3">
-            <a:schemeClr val="accent1"/>
-          </a:fillRef>
-          <a:effectRef idx="2">
-            <a:schemeClr val="accent1"/>
-          </a:effectRef>
-          <a:fontRef idx="minor">
-            <a:schemeClr val="lt1"/>
-          </a:fontRef>
-        </p:style>
-        <p:txBody>
-          <a:bodyPr rtlCol="0" anchor="ctr"/>
-          <a:lstStyle/>
-          <a:p>
-            <a:pPr algn="ctr"/>
-          </a:p>
-        </p:txBody>
-      </p:sp>
-      <p:sp>
-        <p:nvSpPr>
-          <p:cNvPr id="20" name="TextBox 19"/>
-          <p:cNvSpPr txBox="1"/>
-          <p:nvPr/>
-        </p:nvSpPr>
-        <p:spPr>
-          <a:xfrm>
-            <a:off x="9144000" y="1920240"/>
-            <a:ext cx="2560320" cy="457200"/>
-          </a:xfrm>
-          <a:prstGeom prst="rect">
-            <a:avLst/>
-          </a:prstGeom>
-          <a:noFill/>
-        </p:spPr>
-        <p:txBody>
-          <a:bodyPr wrap="square" anchor="t">
-            <a:spAutoFit/>
-          </a:bodyPr>
-          <a:lstStyle/>
-          <a:p>
-            <a:pPr algn="ctr">
-              <a:spcAft>
-                <a:spcPts val="600"/>
-              </a:spcAft>
-            </a:pPr>
-            <a:r>
-              <a:rPr sz="1600" b="1">
-                <a:solidFill>
-                  <a:srgbClr val="FFFFFF"/>
-                </a:solidFill>
-                <a:latin typeface="Calibri"/>
-              </a:rPr>
-              <a:t>CodeMender Runner</a:t>
-            </a:r>
-          </a:p>
-        </p:txBody>
-      </p:sp>
-      <p:sp>
-        <p:nvSpPr>
-          <p:cNvPr id="21" name="TextBox 20"/>
-          <p:cNvSpPr txBox="1"/>
-          <p:nvPr/>
-        </p:nvSpPr>
-        <p:spPr>
-          <a:xfrm>
-            <a:off x="9144000" y="2560320"/>
-            <a:ext cx="2560320" cy="914400"/>
-          </a:xfrm>
-          <a:prstGeom prst="rect">
-            <a:avLst/>
-          </a:prstGeom>
-          <a:noFill/>
-        </p:spPr>
-        <p:txBody>
-          <a:bodyPr wrap="square" anchor="t">
-            <a:spAutoFit/>
-          </a:bodyPr>
-          <a:lstStyle/>
-          <a:p>
-            <a:pPr algn="ctr">
-              <a:spcAft>
-                <a:spcPts val="600"/>
-              </a:spcAft>
-            </a:pPr>
-            <a:r>
-              <a:rPr sz="1300" b="0">
-                <a:solidFill>
-                  <a:srgbClr val="FFFFFF"/>
-                </a:solidFill>
-                <a:latin typeface="Calibri"/>
-              </a:rPr>
-              <a:t>Cloud Run sandbox · cm CLI</a:t>
-            </a:r>
-          </a:p>
-          <a:p>
-            <a:pPr algn="ctr">
-              <a:spcAft>
-                <a:spcPts val="600"/>
-              </a:spcAft>
-            </a:pPr>
-            <a:r>
-              <a:rPr sz="1300" b="0">
-                <a:solidFill>
-                  <a:srgbClr val="FFFFFF"/>
-                </a:solidFill>
-                <a:latin typeface="Calibri"/>
-              </a:rPr>
-              <a:t>find · verify · fix</a:t>
-            </a:r>
-          </a:p>
-        </p:txBody>
-      </p:sp>
-      <p:sp>
-        <p:nvSpPr>
-          <p:cNvPr id="22" name="TextBox 21"/>
-          <p:cNvSpPr txBox="1"/>
-          <p:nvPr/>
-        </p:nvSpPr>
-        <p:spPr>
-          <a:xfrm>
-            <a:off x="365760" y="3931920"/>
-            <a:ext cx="11430000" cy="457200"/>
-          </a:xfrm>
-          <a:prstGeom prst="rect">
-            <a:avLst/>
-          </a:prstGeom>
-          <a:noFill/>
-        </p:spPr>
-        <p:txBody>
-          <a:bodyPr wrap="square" anchor="t">
-            <a:spAutoFit/>
-          </a:bodyPr>
-          <a:lstStyle/>
+              <a:rPr sz="1600" b="0">
+                <a:solidFill>
+                  <a:srgbClr val="202124"/>
+                </a:solidFill>
+                <a:latin typeface="Calibri"/>
+              </a:rPr>
+              <a:t>Today: a built-in, CodeMender-style scanner (24 rules, CWE/OWASP mapped) with a PDF report.</a:t>
+            </a:r>
+          </a:p>
           <a:p>
             <a:pPr algn="l">
               <a:spcAft>
@@ -9568,84 +9623,13 @@
               </a:spcAft>
             </a:pPr>
             <a:r>
-              <a:rPr sz="1500" b="1">
-                <a:solidFill>
-                  <a:srgbClr val="0B1F3A"/>
-                </a:solidFill>
-                <a:latin typeface="Calibri"/>
-              </a:rPr>
-              <a:t>A2A over Vertex AI Agent Engine · IAM-authenticated · both agents registered in Gemini Enterprise</a:t>
-            </a:r>
-          </a:p>
-        </p:txBody>
-      </p:sp>
-      <p:sp>
-        <p:nvSpPr>
-          <p:cNvPr id="23" name="TextBox 22"/>
-          <p:cNvSpPr txBox="1"/>
-          <p:nvPr/>
-        </p:nvSpPr>
-        <p:spPr>
-          <a:xfrm>
-            <a:off x="365760" y="4480560"/>
-            <a:ext cx="11430000" cy="1828800"/>
-          </a:xfrm>
-          <a:prstGeom prst="rect">
-            <a:avLst/>
-          </a:prstGeom>
-          <a:noFill/>
-        </p:spPr>
-        <p:txBody>
-          <a:bodyPr wrap="square" anchor="t">
-            <a:spAutoFit/>
-          </a:bodyPr>
-          <a:lstStyle/>
-          <a:p>
-            <a:pPr algn="l">
-              <a:spcAft>
-                <a:spcPts val="600"/>
-              </a:spcAft>
-            </a:pPr>
-            <a:r>
               <a:rPr sz="1600" b="0">
                 <a:solidFill>
                   <a:srgbClr val="202124"/>
                 </a:solidFill>
                 <a:latin typeface="Calibri"/>
               </a:rPr>
-              <a:t>1. Defect-Fix agent delegates repo analysis to CodeMender over A2A.</a:t>
-            </a:r>
-          </a:p>
-          <a:p>
-            <a:pPr algn="l">
-              <a:spcAft>
-                <a:spcPts val="600"/>
-              </a:spcAft>
-            </a:pPr>
-            <a:r>
-              <a:rPr sz="1600" b="0">
-                <a:solidFill>
-                  <a:srgbClr val="202124"/>
-                </a:solidFill>
-                <a:latin typeface="Calibri"/>
-              </a:rPr>
-              <a:t>2. CodeMender returns severity, CWE/OWASP, patches and report links.</a:t>
-            </a:r>
-          </a:p>
-          <a:p>
-            <a:pPr algn="l">
-              <a:spcAft>
-                <a:spcPts val="600"/>
-              </a:spcAft>
-            </a:pPr>
-            <a:r>
-              <a:rPr sz="1600" b="0">
-                <a:solidFill>
-                  <a:srgbClr val="202124"/>
-                </a:solidFill>
-                <a:latin typeface="Calibri"/>
-              </a:rPr>
-              <a:t>3. Defect-Fix agent applies approved fixes and re-runs analysis to confirm.</a:t>
+              <a:t>Next: call it from the Defect-Fix agent, and connect the real CodeMender CLI (exploit verification, validated fixes).</a:t>
             </a:r>
           </a:p>
         </p:txBody>

</xml_diff>